<commit_message>
fix(fixtures): scrub account data PowerPoint stamped into its decks
PowerPoint wrote the signed-in account's name into docProps/core.xml
(lastModifiedBy) of every deck in fixtures/pptx/powerpoint/, added the
computer's sensitivity label part (docMetadata/LabelInfo.xml, with the
organisation's tenant id), and signed the comment in
pitch-deck-comment.pptx with the account's name, initials, user id and
a derived author id in ppt/authors.xml.

scripts/powerpoint-resave.ps1 now scrubs each deck after saving it, as
excel-resave.ps1 does: lastModifiedBy becomes the fixture generator,
the label part and its references go, and comment authors become the
invented "Jordan Vale" with an invented id. -ScrubOnly applies the same
scrub to the committed decks without opening PowerPoint; every part not
edited keeps its exact bytes, compression and timestamp.

Co-Authored-By: Claude Opus 5.5 <noreply@anthropic.com>
Signed-off-by: Hrishikesh Vedantam <hrishikesh@meridiandatalabs.com>
</commit_message>
<xml_diff>
--- a/fixtures/pptx/powerpoint/pitch-deck-comment.pptx
+++ b/fixtures/pptx/powerpoint/pitch-deck-comment.pptx
@@ -29,7 +29,7 @@
 
 <file path=ppt/authors.xml><?xml version="1.0" encoding="utf-8"?>
 <p188:authorLst xmlns:a="http://schemas.openxmlformats.org/drawingml/2006/main" xmlns:r="http://schemas.openxmlformats.org/officeDocument/2006/relationships" xmlns:p188="http://schemas.microsoft.com/office/powerpoint/2018/8/main">
-  <p188:author id="{3D364E83-F875-9B65-87E1-2C42D7FE0BB5}" name="Hrishikesh Vedantam" initials="HV" userId="S::hvedanta@uwaterloo.ca::8d371cb0-ea12-4f5c-a7f6-7a89d0389498" providerId="AD"/>
+  <p188:author id="{00000000-0000-4000-8000-D12}" name="Jordan Vale" initials="JV" userId="Jordan Vale" providerId="None"/>
 </p188:authorLst>
 </file>
 
@@ -167,7 +167,7 @@
 
 <file path=ppt/comments/modernComment_105_3BBA53AB.xml><?xml version="1.0" encoding="utf-8"?>
 <p188:cmLst xmlns:a="http://schemas.openxmlformats.org/drawingml/2006/main" xmlns:r="http://schemas.openxmlformats.org/officeDocument/2006/relationships" xmlns:p188="http://schemas.microsoft.com/office/powerpoint/2018/8/main">
-  <p188:cm id="{A83B9BF4-B9EC-4DEA-8DFB-334E8431B123}" authorId="{3D364E83-F875-9B65-87E1-2C42D7FE0BB5}" created="2026-10-17T16:47:48.942">
+  <p188:cm id="{A83B9BF4-B9EC-4DEA-8DFB-334E8431B123}" authorId="{00000000-0000-4000-8000-D12}" created="2026-10-17T16:47:48.942">
     <pc:sldMkLst xmlns:pc="http://schemas.microsoft.com/office/powerpoint/2013/main/command">
       <pc:docMk/>
       <pc:sldMk cId="1002066859" sldId="261"/>
@@ -1827,10 +1827,4 @@
   <a:objectDefaults/>
   <a:extraClrSchemeLst/>
 </a:theme>
-</file>
-
-<file path=docMetadata/LabelInfo.xml><?xml version="1.0" encoding="utf-8"?>
-<clbl:labelList xmlns:clbl="http://schemas.microsoft.com/office/2020/mipLabelMetadata">
-  <clbl:label id="{a9ee03e0-b78c-4998-8bf4-79b266b85105}" enabled="1" method="Standard" siteId="{723a5a87-f39a-4a22-9247-3fc240c01396}" contentBits="0" removed="0"/>
-</clbl:labelList>
 </file>
</xml_diff>